<commit_message>
Enlarge card text in watercolor deck and add PDF preview
Co-Authored-By: Claude Sonnet 5.5 <noreply@anthropic.com>
Claude-Session: https://claude.ai/code/session_01HSHZ9n9iJqejt3S7RrREuS
</commit_message>
<xml_diff>
--- a/chronic-care-media/examples/ckm-project-watercolor.pptx
+++ b/chronic-care-media/examples/ckm-project-watercolor.pptx
@@ -2602,7 +2602,7 @@
                 <a:ea typeface="微軟正黑體" pitchFamily="34" charset="-122"/>
                 <a:cs typeface="微軟正黑體" pitchFamily="34" charset="-120"/>
               </a:rPr>
-              <a:t>第 1 支｜心腎代謝是一家人</a:t>
+              <a:t>第 1 支｜認識</a:t>
             </a:r>
             <a:endParaRPr lang="en-US" sz="1600" dirty="0"/>
           </a:p>
@@ -2631,12 +2631,12 @@
           <a:p>
             <a:pPr indent="0" marL="0">
               <a:spcAft>
-                <a:spcPts val="300"/>
+                <a:spcPts val="400"/>
               </a:spcAft>
               <a:buNone/>
             </a:pPr>
             <a:r>
-              <a:rPr lang="en-US" sz="1300" dirty="0">
+              <a:rPr lang="en-US" sz="1500" dirty="0">
                 <a:solidFill>
                   <a:srgbClr val="3D3D3D"/>
                 </a:solidFill>
@@ -2644,9 +2644,9 @@
                 <a:ea typeface="微軟正黑體" pitchFamily="34" charset="-122"/>
                 <a:cs typeface="微軟正黑體" pitchFamily="34" charset="-120"/>
               </a:rPr>
-              <a:t>認識：三者互相影響，一起追蹤更有效</a:t>
-            </a:r>
-            <a:endParaRPr lang="en-US" sz="1300" dirty="0"/>
+              <a:t>「心腎代謝是一家人」：三者互相影響，一起追蹤更有效</a:t>
+            </a:r>
+            <a:endParaRPr lang="en-US" sz="1500" dirty="0"/>
           </a:p>
         </p:txBody>
       </p:sp>
@@ -2737,7 +2737,7 @@
                 <a:ea typeface="微軟正黑體" pitchFamily="34" charset="-122"/>
                 <a:cs typeface="微軟正黑體" pitchFamily="34" charset="-120"/>
               </a:rPr>
-              <a:t>第 2 支｜在家顧好自己</a:t>
+              <a:t>第 2 支｜日常</a:t>
             </a:r>
             <a:endParaRPr lang="en-US" sz="1600" dirty="0"/>
           </a:p>
@@ -2766,12 +2766,12 @@
           <a:p>
             <a:pPr indent="0" marL="0">
               <a:spcAft>
-                <a:spcPts val="300"/>
+                <a:spcPts val="400"/>
               </a:spcAft>
               <a:buNone/>
             </a:pPr>
             <a:r>
-              <a:rPr lang="en-US" sz="1300" dirty="0">
+              <a:rPr lang="en-US" sz="1500" dirty="0">
                 <a:solidFill>
                   <a:srgbClr val="3D3D3D"/>
                 </a:solidFill>
@@ -2779,9 +2779,9 @@
                 <a:ea typeface="微軟正黑體" pitchFamily="34" charset="-122"/>
                 <a:cs typeface="微軟正黑體" pitchFamily="34" charset="-120"/>
               </a:rPr>
-              <a:t>日常：固定時間量測並記錄，家人協助</a:t>
-            </a:r>
-            <a:endParaRPr lang="en-US" sz="1300" dirty="0"/>
+              <a:t>「在家顧好自己」：固定時間量測並記錄，家人協助</a:t>
+            </a:r>
+            <a:endParaRPr lang="en-US" sz="1500" dirty="0"/>
           </a:p>
         </p:txBody>
       </p:sp>
@@ -2872,7 +2872,7 @@
                 <a:ea typeface="微軟正黑體" pitchFamily="34" charset="-122"/>
                 <a:cs typeface="微軟正黑體" pitchFamily="34" charset="-120"/>
               </a:rPr>
-              <a:t>第 3 支｜看診不自己亂加減</a:t>
+              <a:t>第 3 支｜用藥</a:t>
             </a:r>
             <a:endParaRPr lang="en-US" sz="1600" dirty="0"/>
           </a:p>
@@ -2901,12 +2901,12 @@
           <a:p>
             <a:pPr indent="0" marL="0">
               <a:spcAft>
-                <a:spcPts val="300"/>
+                <a:spcPts val="400"/>
               </a:spcAft>
               <a:buNone/>
             </a:pPr>
             <a:r>
-              <a:rPr lang="en-US" sz="1300" dirty="0">
+              <a:rPr lang="en-US" sz="1500" dirty="0">
                 <a:solidFill>
                   <a:srgbClr val="3D3D3D"/>
                 </a:solidFill>
@@ -2914,9 +2914,9 @@
                 <a:ea typeface="微軟正黑體" pitchFamily="34" charset="-122"/>
                 <a:cs typeface="微軟正黑體" pitchFamily="34" charset="-120"/>
               </a:rPr>
-              <a:t>用藥：帶藥袋與保健食品，不自行停藥、加藥或買藥</a:t>
-            </a:r>
-            <a:endParaRPr lang="en-US" sz="1300" dirty="0"/>
+              <a:t>「看診不自己亂加減」：帶藥袋與保健食品，不自行停藥、加藥或買藥</a:t>
+            </a:r>
+            <a:endParaRPr lang="en-US" sz="1500" dirty="0"/>
           </a:p>
         </p:txBody>
       </p:sp>
@@ -3293,13 +3293,13 @@
           <a:p>
             <a:pPr marL="342900" indent="-342900">
               <a:spcAft>
-                <a:spcPts val="300"/>
+                <a:spcPts val="400"/>
               </a:spcAft>
               <a:buSzPct val="100000"/>
               <a:buChar char="•"/>
             </a:pPr>
             <a:r>
-              <a:rPr lang="en-US" sz="1300" dirty="0">
+              <a:rPr lang="en-US" sz="1500" dirty="0">
                 <a:solidFill>
                   <a:srgbClr val="3D3D3D"/>
                 </a:solidFill>
@@ -3309,18 +3309,18 @@
               </a:rPr>
               <a:t>訊息依院內最新指引，標註版本</a:t>
             </a:r>
-            <a:endParaRPr lang="en-US" sz="1300" dirty="0"/>
+            <a:endParaRPr lang="en-US" sz="1500" dirty="0"/>
           </a:p>
           <a:p>
             <a:pPr marL="342900" indent="-342900">
               <a:spcAft>
-                <a:spcPts val="300"/>
+                <a:spcPts val="400"/>
               </a:spcAft>
               <a:buSzPct val="100000"/>
               <a:buChar char="•"/>
             </a:pPr>
             <a:r>
-              <a:rPr lang="en-US" sz="1300" dirty="0">
+              <a:rPr lang="en-US" sz="1500" dirty="0">
                 <a:solidFill>
                   <a:srgbClr val="3D3D3D"/>
                 </a:solidFill>
@@ -3330,7 +3330,7 @@
               </a:rPr>
               <a:t>無自創數值、劑量；步驟圖由專業人員審</a:t>
             </a:r>
-            <a:endParaRPr lang="en-US" sz="1300" dirty="0"/>
+            <a:endParaRPr lang="en-US" sz="1500" dirty="0"/>
           </a:p>
         </p:txBody>
       </p:sp>
@@ -3450,13 +3450,13 @@
           <a:p>
             <a:pPr marL="342900" indent="-342900">
               <a:spcAft>
-                <a:spcPts val="300"/>
+                <a:spcPts val="400"/>
               </a:spcAft>
               <a:buSzPct val="100000"/>
               <a:buChar char="•"/>
             </a:pPr>
             <a:r>
-              <a:rPr lang="en-US" sz="1300" dirty="0">
+              <a:rPr lang="en-US" sz="1500" dirty="0">
                 <a:solidFill>
                   <a:srgbClr val="3D3D3D"/>
                 </a:solidFill>
@@ -3466,18 +3466,18 @@
               </a:rPr>
               <a:t>手指、臉部、器材構造、角色一致性</a:t>
             </a:r>
-            <a:endParaRPr lang="en-US" sz="1300" dirty="0"/>
+            <a:endParaRPr lang="en-US" sz="1500" dirty="0"/>
           </a:p>
           <a:p>
             <a:pPr marL="342900" indent="-342900">
               <a:spcAft>
-                <a:spcPts val="300"/>
+                <a:spcPts val="400"/>
               </a:spcAft>
               <a:buSzPct val="100000"/>
               <a:buChar char="•"/>
             </a:pPr>
             <a:r>
-              <a:rPr lang="en-US" sz="1300" dirty="0">
+              <a:rPr lang="en-US" sz="1500" dirty="0">
                 <a:solidFill>
                   <a:srgbClr val="3D3D3D"/>
                 </a:solidFill>
@@ -3487,7 +3487,7 @@
               </a:rPr>
               <a:t>影片無閃爍、變形、換人</a:t>
             </a:r>
-            <a:endParaRPr lang="en-US" sz="1300" dirty="0"/>
+            <a:endParaRPr lang="en-US" sz="1500" dirty="0"/>
           </a:p>
         </p:txBody>
       </p:sp>
@@ -3607,13 +3607,13 @@
           <a:p>
             <a:pPr marL="342900" indent="-342900">
               <a:spcAft>
-                <a:spcPts val="300"/>
+                <a:spcPts val="400"/>
               </a:spcAft>
               <a:buSzPct val="100000"/>
               <a:buChar char="•"/>
             </a:pPr>
             <a:r>
-              <a:rPr lang="en-US" sz="1300" dirty="0">
+              <a:rPr lang="en-US" sz="1500" dirty="0">
                 <a:solidFill>
                   <a:srgbClr val="3D3D3D"/>
                 </a:solidFill>
@@ -3623,18 +3623,18 @@
               </a:rPr>
               <a:t>一頁一重點、大字高對比</a:t>
             </a:r>
-            <a:endParaRPr lang="en-US" sz="1300" dirty="0"/>
+            <a:endParaRPr lang="en-US" sz="1500" dirty="0"/>
           </a:p>
           <a:p>
             <a:pPr marL="342900" indent="-342900">
               <a:spcAft>
-                <a:spcPts val="300"/>
+                <a:spcPts val="400"/>
               </a:spcAft>
               <a:buSzPct val="100000"/>
               <a:buChar char="•"/>
             </a:pPr>
             <a:r>
-              <a:rPr lang="en-US" sz="1300" dirty="0">
+              <a:rPr lang="en-US" sz="1500" dirty="0">
                 <a:solidFill>
                   <a:srgbClr val="3D3D3D"/>
                 </a:solidFill>
@@ -3644,7 +3644,7 @@
               </a:rPr>
               <a:t>語速偏慢、附字幕、teach-back 設計</a:t>
             </a:r>
-            <a:endParaRPr lang="en-US" sz="1300" dirty="0"/>
+            <a:endParaRPr lang="en-US" sz="1500" dirty="0"/>
           </a:p>
         </p:txBody>
       </p:sp>
@@ -3764,13 +3764,13 @@
           <a:p>
             <a:pPr marL="342900" indent="-342900">
               <a:spcAft>
-                <a:spcPts val="300"/>
+                <a:spcPts val="400"/>
               </a:spcAft>
               <a:buSzPct val="100000"/>
               <a:buChar char="•"/>
             </a:pPr>
             <a:r>
-              <a:rPr lang="en-US" sz="1300" dirty="0">
+              <a:rPr lang="en-US" sz="1500" dirty="0">
                 <a:solidFill>
                   <a:srgbClr val="3D3D3D"/>
                 </a:solidFill>
@@ -3780,18 +3780,18 @@
               </a:rPr>
               <a:t>不使用病人資料與真人肖像</a:t>
             </a:r>
-            <a:endParaRPr lang="en-US" sz="1300" dirty="0"/>
+            <a:endParaRPr lang="en-US" sz="1500" dirty="0"/>
           </a:p>
           <a:p>
             <a:pPr marL="342900" indent="-342900">
               <a:spcAft>
-                <a:spcPts val="300"/>
+                <a:spcPts val="400"/>
               </a:spcAft>
               <a:buSzPct val="100000"/>
               <a:buChar char="•"/>
             </a:pPr>
             <a:r>
-              <a:rPr lang="en-US" sz="1300" dirty="0">
+              <a:rPr lang="en-US" sz="1500" dirty="0">
                 <a:solidFill>
                   <a:srgbClr val="3D3D3D"/>
                 </a:solidFill>
@@ -3801,7 +3801,7 @@
               </a:rPr>
               <a:t>醫療廣告規範請法規／公關確認；留存提示詞與審核紀錄</a:t>
             </a:r>
-            <a:endParaRPr lang="en-US" sz="1300" dirty="0"/>
+            <a:endParaRPr lang="en-US" sz="1500" dirty="0"/>
           </a:p>
         </p:txBody>
       </p:sp>
@@ -5751,12 +5751,12 @@
           <a:p>
             <a:pPr indent="0" marL="0">
               <a:spcAft>
-                <a:spcPts val="300"/>
+                <a:spcPts val="400"/>
               </a:spcAft>
               <a:buNone/>
             </a:pPr>
             <a:r>
-              <a:rPr lang="en-US" sz="1300" dirty="0">
+              <a:rPr lang="en-US" sz="1500" dirty="0">
                 <a:solidFill>
                   <a:srgbClr val="3D3D3D"/>
                 </a:solidFill>
@@ -5766,7 +5766,7 @@
               </a:rPr>
               <a:t>生成圖片、影片與語音可能需訂閱或點數，金額依所選平台而定；建議先做單張與 LINE 圖卡，影片先小量測試。使用前須經資訊單位確認工具與資料政策。</a:t>
             </a:r>
-            <a:endParaRPr lang="en-US" sz="1300" dirty="0"/>
+            <a:endParaRPr lang="en-US" sz="1500" dirty="0"/>
           </a:p>
         </p:txBody>
       </p:sp>
@@ -6058,13 +6058,13 @@
           <a:p>
             <a:pPr marL="342900" indent="-342900">
               <a:spcAft>
-                <a:spcPts val="300"/>
+                <a:spcPts val="400"/>
               </a:spcAft>
               <a:buSzPct val="100000"/>
               <a:buChar char="•"/>
             </a:pPr>
             <a:r>
-              <a:rPr lang="en-US" sz="1300" dirty="0">
+              <a:rPr lang="en-US" sz="1800" dirty="0">
                 <a:solidFill>
                   <a:srgbClr val="3D3D3D"/>
                 </a:solidFill>
@@ -6074,18 +6074,18 @@
               </a:rPr>
               <a:t>指定臨床審核人員與簽核流程</a:t>
             </a:r>
-            <a:endParaRPr lang="en-US" sz="1300" dirty="0"/>
+            <a:endParaRPr lang="en-US" sz="1800" dirty="0"/>
           </a:p>
           <a:p>
             <a:pPr marL="342900" indent="-342900">
               <a:spcAft>
-                <a:spcPts val="300"/>
+                <a:spcPts val="400"/>
               </a:spcAft>
               <a:buSzPct val="100000"/>
               <a:buChar char="•"/>
             </a:pPr>
             <a:r>
-              <a:rPr lang="en-US" sz="1300" dirty="0">
+              <a:rPr lang="en-US" sz="1800" dirty="0">
                 <a:solidFill>
                   <a:srgbClr val="3D3D3D"/>
                 </a:solidFill>
@@ -6095,18 +6095,18 @@
               </a:rPr>
               <a:t>確認可使用的生成工具與預算</a:t>
             </a:r>
-            <a:endParaRPr lang="en-US" sz="1300" dirty="0"/>
+            <a:endParaRPr lang="en-US" sz="1800" dirty="0"/>
           </a:p>
           <a:p>
             <a:pPr marL="342900" indent="-342900">
               <a:spcAft>
-                <a:spcPts val="300"/>
+                <a:spcPts val="400"/>
               </a:spcAft>
               <a:buSzPct val="100000"/>
               <a:buChar char="•"/>
             </a:pPr>
             <a:r>
-              <a:rPr lang="en-US" sz="1300" dirty="0">
+              <a:rPr lang="en-US" sz="1800" dirty="0">
                 <a:solidFill>
                   <a:srgbClr val="3D3D3D"/>
                 </a:solidFill>
@@ -6116,18 +6116,18 @@
               </a:rPr>
               <a:t>確認法規／公關審查單位</a:t>
             </a:r>
-            <a:endParaRPr lang="en-US" sz="1300" dirty="0"/>
+            <a:endParaRPr lang="en-US" sz="1800" dirty="0"/>
           </a:p>
           <a:p>
             <a:pPr marL="342900" indent="-342900">
               <a:spcAft>
-                <a:spcPts val="300"/>
+                <a:spcPts val="400"/>
               </a:spcAft>
               <a:buSzPct val="100000"/>
               <a:buChar char="•"/>
             </a:pPr>
             <a:r>
-              <a:rPr lang="en-US" sz="1300" dirty="0">
+              <a:rPr lang="en-US" sz="1800" dirty="0">
                 <a:solidFill>
                   <a:srgbClr val="3D3D3D"/>
                 </a:solidFill>
@@ -6137,7 +6137,7 @@
               </a:rPr>
               <a:t>決定試辦場域與期間</a:t>
             </a:r>
-            <a:endParaRPr lang="en-US" sz="1300" dirty="0"/>
+            <a:endParaRPr lang="en-US" sz="1800" dirty="0"/>
           </a:p>
         </p:txBody>
       </p:sp>
@@ -6257,13 +6257,13 @@
           <a:p>
             <a:pPr marL="342900" indent="-342900">
               <a:spcAft>
-                <a:spcPts val="300"/>
+                <a:spcPts val="400"/>
               </a:spcAft>
               <a:buSzPct val="100000"/>
               <a:buChar char="•"/>
             </a:pPr>
             <a:r>
-              <a:rPr lang="en-US" sz="1300" dirty="0">
+              <a:rPr lang="en-US" sz="1800" dirty="0">
                 <a:solidFill>
                   <a:srgbClr val="3D3D3D"/>
                 </a:solidFill>
@@ -6273,18 +6273,18 @@
               </a:rPr>
               <a:t>臨床團隊補齊 6 項院內欄位</a:t>
             </a:r>
-            <a:endParaRPr lang="en-US" sz="1300" dirty="0"/>
+            <a:endParaRPr lang="en-US" sz="1800" dirty="0"/>
           </a:p>
           <a:p>
             <a:pPr marL="342900" indent="-342900">
               <a:spcAft>
-                <a:spcPts val="300"/>
+                <a:spcPts val="400"/>
               </a:spcAft>
               <a:buSzPct val="100000"/>
               <a:buChar char="•"/>
             </a:pPr>
             <a:r>
-              <a:rPr lang="en-US" sz="1300" dirty="0">
+              <a:rPr lang="en-US" sz="1800" dirty="0">
                 <a:solidFill>
                   <a:srgbClr val="3D3D3D"/>
                 </a:solidFill>
@@ -6294,18 +6294,18 @@
               </a:rPr>
               <a:t>先完成單張與 LINE 圖卡送審</a:t>
             </a:r>
-            <a:endParaRPr lang="en-US" sz="1300" dirty="0"/>
+            <a:endParaRPr lang="en-US" sz="1800" dirty="0"/>
           </a:p>
           <a:p>
             <a:pPr marL="342900" indent="-342900">
               <a:spcAft>
-                <a:spcPts val="300"/>
+                <a:spcPts val="400"/>
               </a:spcAft>
               <a:buSzPct val="100000"/>
               <a:buChar char="•"/>
             </a:pPr>
             <a:r>
-              <a:rPr lang="en-US" sz="1300" dirty="0">
+              <a:rPr lang="en-US" sz="1800" dirty="0">
                 <a:solidFill>
                   <a:srgbClr val="3D3D3D"/>
                 </a:solidFill>
@@ -6315,18 +6315,18 @@
               </a:rPr>
               <a:t>影片小量測試後擴大</a:t>
             </a:r>
-            <a:endParaRPr lang="en-US" sz="1300" dirty="0"/>
+            <a:endParaRPr lang="en-US" sz="1800" dirty="0"/>
           </a:p>
           <a:p>
             <a:pPr marL="342900" indent="-342900">
               <a:spcAft>
-                <a:spcPts val="300"/>
+                <a:spcPts val="400"/>
               </a:spcAft>
               <a:buSzPct val="100000"/>
               <a:buChar char="•"/>
             </a:pPr>
             <a:r>
-              <a:rPr lang="en-US" sz="1300" dirty="0">
+              <a:rPr lang="en-US" sz="1800" dirty="0">
                 <a:solidFill>
                   <a:srgbClr val="3D3D3D"/>
                 </a:solidFill>
@@ -6336,7 +6336,7 @@
               </a:rPr>
               <a:t>試辦後依成效指標檢討與擴及其他病種</a:t>
             </a:r>
-            <a:endParaRPr lang="en-US" sz="1300" dirty="0"/>
+            <a:endParaRPr lang="en-US" sz="1800" dirty="0"/>
           </a:p>
         </p:txBody>
       </p:sp>
@@ -7450,14 +7450,14 @@
           <a:ln/>
         </p:spPr>
         <p:txBody>
-          <a:bodyPr wrap="square" lIns="50800" tIns="50800" rIns="50800" bIns="50800" rtlCol="0" anchor="t"/>
+          <a:bodyPr wrap="square" lIns="76200" tIns="76200" rIns="76200" bIns="76200" rtlCol="0" anchor="t"/>
           <a:lstStyle/>
           <a:p>
             <a:pPr indent="0" marL="0">
               <a:buNone/>
             </a:pPr>
             <a:r>
-              <a:rPr lang="en-US" sz="1500" dirty="0">
+              <a:rPr lang="en-US" sz="1700" dirty="0">
                 <a:solidFill>
                   <a:srgbClr val="3D3D3D"/>
                 </a:solidFill>
@@ -7467,7 +7467,7 @@
               </a:rPr>
               <a:t>衛教單張多為文字，內容偏專業；個管師需依個案自行補充說明</a:t>
             </a:r>
-            <a:endParaRPr lang="en-US" sz="1500" dirty="0"/>
+            <a:endParaRPr lang="en-US" sz="1700" dirty="0"/>
           </a:p>
         </p:txBody>
       </p:sp>
@@ -7573,14 +7573,14 @@
           <a:ln/>
         </p:spPr>
         <p:txBody>
-          <a:bodyPr wrap="square" lIns="50800" tIns="50800" rIns="50800" bIns="50800" rtlCol="0" anchor="t"/>
+          <a:bodyPr wrap="square" lIns="76200" tIns="76200" rIns="76200" bIns="76200" rtlCol="0" anchor="t"/>
           <a:lstStyle/>
           <a:p>
             <a:pPr indent="0" marL="0">
               <a:buNone/>
             </a:pPr>
             <a:r>
-              <a:rPr lang="en-US" sz="1500" dirty="0">
+              <a:rPr lang="en-US" sz="1700" dirty="0">
                 <a:solidFill>
                   <a:srgbClr val="3D3D3D"/>
                 </a:solidFill>
@@ -7590,7 +7590,7 @@
               </a:rPr>
               <a:t>素材製作耗時、風格不一；長者識能落差；人力有限，更新不易</a:t>
             </a:r>
-            <a:endParaRPr lang="en-US" sz="1500" dirty="0"/>
+            <a:endParaRPr lang="en-US" sz="1700" dirty="0"/>
           </a:p>
         </p:txBody>
       </p:sp>
@@ -7696,14 +7696,14 @@
           <a:ln/>
         </p:spPr>
         <p:txBody>
-          <a:bodyPr wrap="square" lIns="50800" tIns="50800" rIns="50800" bIns="50800" rtlCol="0" anchor="t"/>
+          <a:bodyPr wrap="square" lIns="76200" tIns="76200" rIns="76200" bIns="76200" rtlCol="0" anchor="t"/>
           <a:lstStyle/>
           <a:p>
             <a:pPr indent="0" marL="0">
               <a:buNone/>
             </a:pPr>
             <a:r>
-              <a:rPr lang="en-US" sz="1500" dirty="0">
+              <a:rPr lang="en-US" sz="1700" dirty="0">
                 <a:solidFill>
                   <a:srgbClr val="3D3D3D"/>
                 </a:solidFill>
@@ -7713,7 +7713,7 @@
               </a:rPr>
               <a:t>以 AI 輔助生成插圖與分鏡，文字與數值由臨床人員確認並後製</a:t>
             </a:r>
-            <a:endParaRPr lang="en-US" sz="1500" dirty="0"/>
+            <a:endParaRPr lang="en-US" sz="1700" dirty="0"/>
           </a:p>
         </p:txBody>
       </p:sp>
@@ -7819,14 +7819,14 @@
           <a:ln/>
         </p:spPr>
         <p:txBody>
-          <a:bodyPr wrap="square" lIns="50800" tIns="50800" rIns="50800" bIns="50800" rtlCol="0" anchor="t"/>
+          <a:bodyPr wrap="square" lIns="76200" tIns="76200" rIns="76200" bIns="76200" rtlCol="0" anchor="t"/>
           <a:lstStyle/>
           <a:p>
             <a:pPr indent="0" marL="0">
               <a:buNone/>
             </a:pPr>
             <a:r>
-              <a:rPr lang="en-US" sz="1500" dirty="0">
+              <a:rPr lang="en-US" sz="1700" dirty="0">
                 <a:solidFill>
                   <a:srgbClr val="3D3D3D"/>
                 </a:solidFill>
@@ -7836,7 +7836,7 @@
               </a:rPr>
               <a:t>縮短製作時間、素材一致、可系列化重複使用，並可追蹤成效</a:t>
             </a:r>
-            <a:endParaRPr lang="en-US" sz="1500" dirty="0"/>
+            <a:endParaRPr lang="en-US" sz="1700" dirty="0"/>
           </a:p>
         </p:txBody>
       </p:sp>
@@ -8167,12 +8167,12 @@
           <a:p>
             <a:pPr indent="0" marL="0">
               <a:spcAft>
-                <a:spcPts val="300"/>
+                <a:spcPts val="400"/>
               </a:spcAft>
               <a:buNone/>
             </a:pPr>
             <a:r>
-              <a:rPr lang="en-US" sz="1300" dirty="0">
+              <a:rPr lang="en-US" sz="1500" dirty="0">
                 <a:solidFill>
                   <a:srgbClr val="3D3D3D"/>
                 </a:solidFill>
@@ -8182,7 +8182,7 @@
               </a:rPr>
               <a:t>衛教訊息、數值、用藥與飲食建議；依院內最新指引填入與簽核</a:t>
             </a:r>
-            <a:endParaRPr lang="en-US" sz="1300" dirty="0"/>
+            <a:endParaRPr lang="en-US" sz="1500" dirty="0"/>
           </a:p>
         </p:txBody>
       </p:sp>
@@ -8302,12 +8302,12 @@
           <a:p>
             <a:pPr indent="0" marL="0">
               <a:spcAft>
-                <a:spcPts val="300"/>
+                <a:spcPts val="400"/>
               </a:spcAft>
               <a:buNone/>
             </a:pPr>
             <a:r>
-              <a:rPr lang="en-US" sz="1300" dirty="0">
+              <a:rPr lang="en-US" sz="1500" dirty="0">
                 <a:solidFill>
                   <a:srgbClr val="3D3D3D"/>
                 </a:solidFill>
@@ -8317,7 +8317,7 @@
               </a:rPr>
               <a:t>插圖、角色、情境與運鏡；提示詞固定附「無文字、無數字」</a:t>
             </a:r>
-            <a:endParaRPr lang="en-US" sz="1300" dirty="0"/>
+            <a:endParaRPr lang="en-US" sz="1500" dirty="0"/>
           </a:p>
         </p:txBody>
       </p:sp>
@@ -8437,12 +8437,12 @@
           <a:p>
             <a:pPr indent="0" marL="0">
               <a:spcAft>
-                <a:spcPts val="300"/>
+                <a:spcPts val="400"/>
               </a:spcAft>
               <a:buNone/>
             </a:pPr>
             <a:r>
-              <a:rPr lang="en-US" sz="1300" dirty="0">
+              <a:rPr lang="en-US" sz="1500" dirty="0">
                 <a:solidFill>
                   <a:srgbClr val="3D3D3D"/>
                 </a:solidFill>
@@ -8452,7 +8452,7 @@
               </a:rPr>
               <a:t>畫面文字、數值、院徽、QR Code 一律以 PPT／Canva／剪輯軟體後製</a:t>
             </a:r>
-            <a:endParaRPr lang="en-US" sz="1300" dirty="0"/>
+            <a:endParaRPr lang="en-US" sz="1500" dirty="0"/>
           </a:p>
         </p:txBody>
       </p:sp>
@@ -9708,13 +9708,13 @@
           <a:p>
             <a:pPr marL="342900" indent="-342900">
               <a:spcAft>
-                <a:spcPts val="300"/>
+                <a:spcPts val="400"/>
               </a:spcAft>
               <a:buSzPct val="100000"/>
               <a:buChar char="•"/>
             </a:pPr>
             <a:r>
-              <a:rPr lang="en-US" sz="1300" dirty="0">
+              <a:rPr lang="en-US" sz="1500" dirty="0">
                 <a:solidFill>
                   <a:srgbClr val="3D3D3D"/>
                 </a:solidFill>
@@ -9724,18 +9724,18 @@
               </a:rPr>
               <a:t>65 歲以上，已有高血壓、糖尿病、慢性腎臟病或體重、血脂問題者，及其照顧者</a:t>
             </a:r>
-            <a:endParaRPr lang="en-US" sz="1300" dirty="0"/>
+            <a:endParaRPr lang="en-US" sz="1500" dirty="0"/>
           </a:p>
           <a:p>
             <a:pPr marL="342900" indent="-342900">
               <a:spcAft>
-                <a:spcPts val="300"/>
+                <a:spcPts val="400"/>
               </a:spcAft>
               <a:buSzPct val="100000"/>
               <a:buChar char="•"/>
             </a:pPr>
             <a:r>
-              <a:rPr lang="en-US" sz="1300" dirty="0">
+              <a:rPr lang="en-US" sz="1500" dirty="0">
                 <a:solidFill>
                   <a:srgbClr val="3D3D3D"/>
                 </a:solidFill>
@@ -9745,7 +9745,7 @@
               </a:rPr>
               <a:t>候診區電視、個管師衛教、LINE、診間發放</a:t>
             </a:r>
-            <a:endParaRPr lang="en-US" sz="1300" dirty="0"/>
+            <a:endParaRPr lang="en-US" sz="1500" dirty="0"/>
           </a:p>
         </p:txBody>
       </p:sp>
@@ -9865,13 +9865,13 @@
           <a:p>
             <a:pPr marL="342900" indent="-342900">
               <a:spcAft>
-                <a:spcPts val="300"/>
+                <a:spcPts val="400"/>
               </a:spcAft>
               <a:buSzPct val="100000"/>
               <a:buChar char="•"/>
             </a:pPr>
             <a:r>
-              <a:rPr lang="en-US" sz="1300" dirty="0">
+              <a:rPr lang="en-US" sz="1500" dirty="0">
                 <a:solidFill>
                   <a:srgbClr val="3D3D3D"/>
                 </a:solidFill>
@@ -9881,18 +9881,18 @@
               </a:rPr>
               <a:t>角色：阿花嬤、孫女小芸、個管師</a:t>
             </a:r>
-            <a:endParaRPr lang="en-US" sz="1300" dirty="0"/>
+            <a:endParaRPr lang="en-US" sz="1500" dirty="0"/>
           </a:p>
           <a:p>
             <a:pPr marL="342900" indent="-342900">
               <a:spcAft>
-                <a:spcPts val="300"/>
+                <a:spcPts val="400"/>
               </a:spcAft>
               <a:buSzPct val="100000"/>
               <a:buChar char="•"/>
             </a:pPr>
             <a:r>
-              <a:rPr lang="en-US" sz="1300" dirty="0">
+              <a:rPr lang="en-US" sz="1500" dirty="0">
                 <a:solidFill>
                   <a:srgbClr val="3D3D3D"/>
                 </a:solidFill>
@@ -9902,18 +9902,18 @@
               </a:rPr>
               <a:t>溫暖水彩插畫；台灣日常場景（客廳、市場、診間）</a:t>
             </a:r>
-            <a:endParaRPr lang="en-US" sz="1300" dirty="0"/>
+            <a:endParaRPr lang="en-US" sz="1500" dirty="0"/>
           </a:p>
           <a:p>
             <a:pPr marL="342900" indent="-342900">
               <a:spcAft>
-                <a:spcPts val="300"/>
+                <a:spcPts val="400"/>
               </a:spcAft>
               <a:buSzPct val="100000"/>
               <a:buChar char="•"/>
             </a:pPr>
             <a:r>
-              <a:rPr lang="en-US" sz="1300" dirty="0">
+              <a:rPr lang="en-US" sz="1500" dirty="0">
                 <a:solidFill>
                   <a:srgbClr val="3D3D3D"/>
                 </a:solidFill>
@@ -9923,7 +9923,7 @@
               </a:rPr>
               <a:t>先國語，台語版由母語者校對</a:t>
             </a:r>
-            <a:endParaRPr lang="en-US" sz="1300" dirty="0"/>
+            <a:endParaRPr lang="en-US" sz="1500" dirty="0"/>
           </a:p>
         </p:txBody>
       </p:sp>
@@ -11032,12 +11032,12 @@
           <a:p>
             <a:pPr indent="0" marL="0">
               <a:spcAft>
-                <a:spcPts val="300"/>
+                <a:spcPts val="400"/>
               </a:spcAft>
               <a:buNone/>
             </a:pPr>
             <a:r>
-              <a:rPr lang="en-US" sz="1300" dirty="0">
+              <a:rPr lang="en-US" sz="1500" dirty="0">
                 <a:solidFill>
                   <a:srgbClr val="3D3D3D"/>
                 </a:solidFill>
@@ -11047,7 +11047,7 @@
               </a:rPr>
               <a:t>正在吃的藥、保健食品都帶來</a:t>
             </a:r>
-            <a:endParaRPr lang="en-US" sz="1300" dirty="0"/>
+            <a:endParaRPr lang="en-US" sz="1500" dirty="0"/>
           </a:p>
         </p:txBody>
       </p:sp>
@@ -11167,12 +11167,12 @@
           <a:p>
             <a:pPr indent="0" marL="0">
               <a:spcAft>
-                <a:spcPts val="300"/>
+                <a:spcPts val="400"/>
               </a:spcAft>
               <a:buNone/>
             </a:pPr>
             <a:r>
-              <a:rPr lang="en-US" sz="1300" dirty="0">
+              <a:rPr lang="en-US" sz="1500" dirty="0">
                 <a:solidFill>
                   <a:srgbClr val="3D3D3D"/>
                 </a:solidFill>
@@ -11182,7 +11182,7 @@
               </a:rPr>
               <a:t>在家量的血壓、體重寫下來</a:t>
             </a:r>
-            <a:endParaRPr lang="en-US" sz="1300" dirty="0"/>
+            <a:endParaRPr lang="en-US" sz="1500" dirty="0"/>
           </a:p>
         </p:txBody>
       </p:sp>
@@ -11302,12 +11302,12 @@
           <a:p>
             <a:pPr indent="0" marL="0">
               <a:spcAft>
-                <a:spcPts val="300"/>
+                <a:spcPts val="400"/>
               </a:spcAft>
               <a:buNone/>
             </a:pPr>
             <a:r>
-              <a:rPr lang="en-US" sz="1300" dirty="0">
+              <a:rPr lang="en-US" sz="1500" dirty="0">
                 <a:solidFill>
                   <a:srgbClr val="3D3D3D"/>
                 </a:solidFill>
@@ -11317,7 +11317,7 @@
               </a:rPr>
               <a:t>想問的事先寫下，看診一起問</a:t>
             </a:r>
-            <a:endParaRPr lang="en-US" sz="1300" dirty="0"/>
+            <a:endParaRPr lang="en-US" sz="1500" dirty="0"/>
           </a:p>
         </p:txBody>
       </p:sp>
@@ -11561,13 +11561,13 @@
           <a:p>
             <a:pPr marL="342900" indent="-342900">
               <a:spcAft>
-                <a:spcPts val="300"/>
+                <a:spcPts val="400"/>
               </a:spcAft>
               <a:buSzPct val="100000"/>
               <a:buChar char="•"/>
             </a:pPr>
             <a:r>
-              <a:rPr lang="en-US" sz="1300" dirty="0">
+              <a:rPr lang="en-US" sz="1500" dirty="0">
                 <a:solidFill>
                   <a:srgbClr val="3D3D3D"/>
                 </a:solidFill>
@@ -11577,18 +11577,18 @@
               </a:rPr>
               <a:t>標題 28pt 以上，內文 14pt 以上</a:t>
             </a:r>
-            <a:endParaRPr lang="en-US" sz="1300" dirty="0"/>
+            <a:endParaRPr lang="en-US" sz="1500" dirty="0"/>
           </a:p>
           <a:p>
             <a:pPr marL="342900" indent="-342900">
               <a:spcAft>
-                <a:spcPts val="300"/>
+                <a:spcPts val="400"/>
               </a:spcAft>
               <a:buSzPct val="100000"/>
               <a:buChar char="•"/>
             </a:pPr>
             <a:r>
-              <a:rPr lang="en-US" sz="1300" dirty="0">
+              <a:rPr lang="en-US" sz="1500" dirty="0">
                 <a:solidFill>
                   <a:srgbClr val="3D3D3D"/>
                 </a:solidFill>
@@ -11598,7 +11598,7 @@
               </a:rPr>
               <a:t>待補：追蹤檢查項目、紅旗症狀、聯絡方式</a:t>
             </a:r>
-            <a:endParaRPr lang="en-US" sz="1300" dirty="0"/>
+            <a:endParaRPr lang="en-US" sz="1500" dirty="0"/>
           </a:p>
         </p:txBody>
       </p:sp>

</xml_diff>

<commit_message>
Rewrite slide 3 of watercolor deck as bullet points without data
Co-Authored-By: Claude Sonnet 5.5 <noreply@anthropic.com>
Claude-Session: https://claude.ai/code/session_01HSHZ9n9iJqejt3S7RrREuS
</commit_message>
<xml_diff>
--- a/chronic-care-media/examples/ckm-project-watercolor.pptx
+++ b/chronic-care-media/examples/ckm-project-watercolor.pptx
@@ -7416,7 +7416,7 @@
         <p:spPr>
           <a:xfrm>
             <a:off x="274320" y="1645920"/>
-            <a:ext cx="2011680" cy="2651760"/>
+            <a:ext cx="2011680" cy="2926080"/>
           </a:xfrm>
           <a:prstGeom prst="rect">
             <a:avLst/>
@@ -7440,24 +7440,28 @@
         </p:nvSpPr>
         <p:spPr>
           <a:xfrm>
-            <a:off x="365760" y="1737360"/>
-            <a:ext cx="1828800" cy="2468880"/>
-          </a:xfrm>
-          <a:prstGeom prst="rect">
-            <a:avLst/>
-          </a:prstGeom>
-          <a:noFill/>
-          <a:ln/>
-        </p:spPr>
-        <p:txBody>
-          <a:bodyPr wrap="square" lIns="76200" tIns="76200" rIns="76200" bIns="76200" rtlCol="0" anchor="t"/>
-          <a:lstStyle/>
-          <a:p>
-            <a:pPr indent="0" marL="0">
-              <a:buNone/>
-            </a:pPr>
-            <a:r>
-              <a:rPr lang="en-US" sz="1700" dirty="0">
+            <a:off x="365760" y="1783080"/>
+            <a:ext cx="1828800" cy="2651760"/>
+          </a:xfrm>
+          <a:prstGeom prst="rect">
+            <a:avLst/>
+          </a:prstGeom>
+          <a:noFill/>
+          <a:ln/>
+        </p:spPr>
+        <p:txBody>
+          <a:bodyPr wrap="square" lIns="50800" tIns="50800" rIns="50800" bIns="50800" rtlCol="0" anchor="t"/>
+          <a:lstStyle/>
+          <a:p>
+            <a:pPr marL="342900" indent="-342900">
+              <a:spcAft>
+                <a:spcPts val="1000"/>
+              </a:spcAft>
+              <a:buSzPct val="100000"/>
+              <a:buChar char="•"/>
+            </a:pPr>
+            <a:r>
+              <a:rPr lang="en-US" sz="1500" dirty="0">
                 <a:solidFill>
                   <a:srgbClr val="3D3D3D"/>
                 </a:solidFill>
@@ -7465,9 +7469,51 @@
                 <a:ea typeface="微軟正黑體" pitchFamily="34" charset="-122"/>
                 <a:cs typeface="微軟正黑體" pitchFamily="34" charset="-120"/>
               </a:rPr>
-              <a:t>衛教單張多為文字，內容偏專業；個管師需依個案自行補充說明</a:t>
-            </a:r>
-            <a:endParaRPr lang="en-US" sz="1700" dirty="0"/>
+              <a:t>衛教以單張與口頭說明為主</a:t>
+            </a:r>
+            <a:endParaRPr lang="en-US" sz="1500" dirty="0"/>
+          </a:p>
+          <a:p>
+            <a:pPr marL="342900" indent="-342900">
+              <a:spcAft>
+                <a:spcPts val="1000"/>
+              </a:spcAft>
+              <a:buSzPct val="100000"/>
+              <a:buChar char="•"/>
+            </a:pPr>
+            <a:r>
+              <a:rPr lang="en-US" sz="1500" dirty="0">
+                <a:solidFill>
+                  <a:srgbClr val="3D3D3D"/>
+                </a:solidFill>
+                <a:latin typeface="微軟正黑體" pitchFamily="34" charset="0"/>
+                <a:ea typeface="微軟正黑體" pitchFamily="34" charset="-122"/>
+                <a:cs typeface="微軟正黑體" pitchFamily="34" charset="-120"/>
+              </a:rPr>
+              <a:t>內容多為文字，專業用語較多</a:t>
+            </a:r>
+            <a:endParaRPr lang="en-US" sz="1500" dirty="0"/>
+          </a:p>
+          <a:p>
+            <a:pPr marL="342900" indent="-342900">
+              <a:spcAft>
+                <a:spcPts val="1000"/>
+              </a:spcAft>
+              <a:buSzPct val="100000"/>
+              <a:buChar char="•"/>
+            </a:pPr>
+            <a:r>
+              <a:rPr lang="en-US" sz="1500" dirty="0">
+                <a:solidFill>
+                  <a:srgbClr val="3D3D3D"/>
+                </a:solidFill>
+                <a:latin typeface="微軟正黑體" pitchFamily="34" charset="0"/>
+                <a:ea typeface="微軟正黑體" pitchFamily="34" charset="-122"/>
+                <a:cs typeface="微軟正黑體" pitchFamily="34" charset="-120"/>
+              </a:rPr>
+              <a:t>個管師需依個案逐一補充說明</a:t>
+            </a:r>
+            <a:endParaRPr lang="en-US" sz="1500" dirty="0"/>
           </a:p>
         </p:txBody>
       </p:sp>
@@ -7539,7 +7585,7 @@
         <p:spPr>
           <a:xfrm>
             <a:off x="2468880" y="1645920"/>
-            <a:ext cx="2011680" cy="2651760"/>
+            <a:ext cx="2011680" cy="2926080"/>
           </a:xfrm>
           <a:prstGeom prst="rect">
             <a:avLst/>
@@ -7563,24 +7609,28 @@
         </p:nvSpPr>
         <p:spPr>
           <a:xfrm>
-            <a:off x="2560320" y="1737360"/>
-            <a:ext cx="1828800" cy="2468880"/>
-          </a:xfrm>
-          <a:prstGeom prst="rect">
-            <a:avLst/>
-          </a:prstGeom>
-          <a:noFill/>
-          <a:ln/>
-        </p:spPr>
-        <p:txBody>
-          <a:bodyPr wrap="square" lIns="76200" tIns="76200" rIns="76200" bIns="76200" rtlCol="0" anchor="t"/>
-          <a:lstStyle/>
-          <a:p>
-            <a:pPr indent="0" marL="0">
-              <a:buNone/>
-            </a:pPr>
-            <a:r>
-              <a:rPr lang="en-US" sz="1700" dirty="0">
+            <a:off x="2560320" y="1783080"/>
+            <a:ext cx="1828800" cy="2651760"/>
+          </a:xfrm>
+          <a:prstGeom prst="rect">
+            <a:avLst/>
+          </a:prstGeom>
+          <a:noFill/>
+          <a:ln/>
+        </p:spPr>
+        <p:txBody>
+          <a:bodyPr wrap="square" lIns="50800" tIns="50800" rIns="50800" bIns="50800" rtlCol="0" anchor="t"/>
+          <a:lstStyle/>
+          <a:p>
+            <a:pPr marL="342900" indent="-342900">
+              <a:spcAft>
+                <a:spcPts val="1000"/>
+              </a:spcAft>
+              <a:buSzPct val="100000"/>
+              <a:buChar char="•"/>
+            </a:pPr>
+            <a:r>
+              <a:rPr lang="en-US" sz="1500" dirty="0">
                 <a:solidFill>
                   <a:srgbClr val="3D3D3D"/>
                 </a:solidFill>
@@ -7588,9 +7638,51 @@
                 <a:ea typeface="微軟正黑體" pitchFamily="34" charset="-122"/>
                 <a:cs typeface="微軟正黑體" pitchFamily="34" charset="-120"/>
               </a:rPr>
-              <a:t>素材製作耗時、風格不一；長者識能落差；人力有限，更新不易</a:t>
-            </a:r>
-            <a:endParaRPr lang="en-US" sz="1700" dirty="0"/>
+              <a:t>素材製作耗時，風格與版本不易一致</a:t>
+            </a:r>
+            <a:endParaRPr lang="en-US" sz="1500" dirty="0"/>
+          </a:p>
+          <a:p>
+            <a:pPr marL="342900" indent="-342900">
+              <a:spcAft>
+                <a:spcPts val="1000"/>
+              </a:spcAft>
+              <a:buSzPct val="100000"/>
+              <a:buChar char="•"/>
+            </a:pPr>
+            <a:r>
+              <a:rPr lang="en-US" sz="1500" dirty="0">
+                <a:solidFill>
+                  <a:srgbClr val="3D3D3D"/>
+                </a:solidFill>
+                <a:latin typeface="微軟正黑體" pitchFamily="34" charset="0"/>
+                <a:ea typeface="微軟正黑體" pitchFamily="34" charset="-122"/>
+                <a:cs typeface="微軟正黑體" pitchFamily="34" charset="-120"/>
+              </a:rPr>
+              <a:t>長者與照顧者閱讀、理解有落差</a:t>
+            </a:r>
+            <a:endParaRPr lang="en-US" sz="1500" dirty="0"/>
+          </a:p>
+          <a:p>
+            <a:pPr marL="342900" indent="-342900">
+              <a:spcAft>
+                <a:spcPts val="1000"/>
+              </a:spcAft>
+              <a:buSzPct val="100000"/>
+              <a:buChar char="•"/>
+            </a:pPr>
+            <a:r>
+              <a:rPr lang="en-US" sz="1500" dirty="0">
+                <a:solidFill>
+                  <a:srgbClr val="3D3D3D"/>
+                </a:solidFill>
+                <a:latin typeface="微軟正黑體" pitchFamily="34" charset="0"/>
+                <a:ea typeface="微軟正黑體" pitchFamily="34" charset="-122"/>
+                <a:cs typeface="微軟正黑體" pitchFamily="34" charset="-120"/>
+              </a:rPr>
+              <a:t>素材更新與維護的人力有限</a:t>
+            </a:r>
+            <a:endParaRPr lang="en-US" sz="1500" dirty="0"/>
           </a:p>
         </p:txBody>
       </p:sp>
@@ -7662,7 +7754,7 @@
         <p:spPr>
           <a:xfrm>
             <a:off x="4663440" y="1645920"/>
-            <a:ext cx="2011680" cy="2651760"/>
+            <a:ext cx="2011680" cy="2926080"/>
           </a:xfrm>
           <a:prstGeom prst="rect">
             <a:avLst/>
@@ -7686,24 +7778,28 @@
         </p:nvSpPr>
         <p:spPr>
           <a:xfrm>
-            <a:off x="4754880" y="1737360"/>
-            <a:ext cx="1828800" cy="2468880"/>
-          </a:xfrm>
-          <a:prstGeom prst="rect">
-            <a:avLst/>
-          </a:prstGeom>
-          <a:noFill/>
-          <a:ln/>
-        </p:spPr>
-        <p:txBody>
-          <a:bodyPr wrap="square" lIns="76200" tIns="76200" rIns="76200" bIns="76200" rtlCol="0" anchor="t"/>
-          <a:lstStyle/>
-          <a:p>
-            <a:pPr indent="0" marL="0">
-              <a:buNone/>
-            </a:pPr>
-            <a:r>
-              <a:rPr lang="en-US" sz="1700" dirty="0">
+            <a:off x="4754880" y="1783080"/>
+            <a:ext cx="1828800" cy="2651760"/>
+          </a:xfrm>
+          <a:prstGeom prst="rect">
+            <a:avLst/>
+          </a:prstGeom>
+          <a:noFill/>
+          <a:ln/>
+        </p:spPr>
+        <p:txBody>
+          <a:bodyPr wrap="square" lIns="50800" tIns="50800" rIns="50800" bIns="50800" rtlCol="0" anchor="t"/>
+          <a:lstStyle/>
+          <a:p>
+            <a:pPr marL="342900" indent="-342900">
+              <a:spcAft>
+                <a:spcPts val="1000"/>
+              </a:spcAft>
+              <a:buSzPct val="100000"/>
+              <a:buChar char="•"/>
+            </a:pPr>
+            <a:r>
+              <a:rPr lang="en-US" sz="1500" dirty="0">
                 <a:solidFill>
                   <a:srgbClr val="3D3D3D"/>
                 </a:solidFill>
@@ -7711,9 +7807,51 @@
                 <a:ea typeface="微軟正黑體" pitchFamily="34" charset="-122"/>
                 <a:cs typeface="微軟正黑體" pitchFamily="34" charset="-120"/>
               </a:rPr>
-              <a:t>以 AI 輔助生成插圖與分鏡，文字與數值由臨床人員確認並後製</a:t>
-            </a:r>
-            <a:endParaRPr lang="en-US" sz="1700" dirty="0"/>
+              <a:t>AI 輔助生成插圖與分鏡</a:t>
+            </a:r>
+            <a:endParaRPr lang="en-US" sz="1500" dirty="0"/>
+          </a:p>
+          <a:p>
+            <a:pPr marL="342900" indent="-342900">
+              <a:spcAft>
+                <a:spcPts val="1000"/>
+              </a:spcAft>
+              <a:buSzPct val="100000"/>
+              <a:buChar char="•"/>
+            </a:pPr>
+            <a:r>
+              <a:rPr lang="en-US" sz="1500" dirty="0">
+                <a:solidFill>
+                  <a:srgbClr val="3D3D3D"/>
+                </a:solidFill>
+                <a:latin typeface="微軟正黑體" pitchFamily="34" charset="0"/>
+                <a:ea typeface="微軟正黑體" pitchFamily="34" charset="-122"/>
+                <a:cs typeface="微軟正黑體" pitchFamily="34" charset="-120"/>
+              </a:rPr>
+              <a:t>臨床訊息與數值由臨床人員確認</a:t>
+            </a:r>
+            <a:endParaRPr lang="en-US" sz="1500" dirty="0"/>
+          </a:p>
+          <a:p>
+            <a:pPr marL="342900" indent="-342900">
+              <a:spcAft>
+                <a:spcPts val="1000"/>
+              </a:spcAft>
+              <a:buSzPct val="100000"/>
+              <a:buChar char="•"/>
+            </a:pPr>
+            <a:r>
+              <a:rPr lang="en-US" sz="1500" dirty="0">
+                <a:solidFill>
+                  <a:srgbClr val="3D3D3D"/>
+                </a:solidFill>
+                <a:latin typeface="微軟正黑體" pitchFamily="34" charset="0"/>
+                <a:ea typeface="微軟正黑體" pitchFamily="34" charset="-122"/>
+                <a:cs typeface="微軟正黑體" pitchFamily="34" charset="-120"/>
+              </a:rPr>
+              <a:t>文字後製，發布前人工審核</a:t>
+            </a:r>
+            <a:endParaRPr lang="en-US" sz="1500" dirty="0"/>
           </a:p>
         </p:txBody>
       </p:sp>
@@ -7785,7 +7923,7 @@
         <p:spPr>
           <a:xfrm>
             <a:off x="6858000" y="1645920"/>
-            <a:ext cx="2011680" cy="2651760"/>
+            <a:ext cx="2011680" cy="2926080"/>
           </a:xfrm>
           <a:prstGeom prst="rect">
             <a:avLst/>
@@ -7809,24 +7947,28 @@
         </p:nvSpPr>
         <p:spPr>
           <a:xfrm>
-            <a:off x="6949440" y="1737360"/>
-            <a:ext cx="1828800" cy="2468880"/>
-          </a:xfrm>
-          <a:prstGeom prst="rect">
-            <a:avLst/>
-          </a:prstGeom>
-          <a:noFill/>
-          <a:ln/>
-        </p:spPr>
-        <p:txBody>
-          <a:bodyPr wrap="square" lIns="76200" tIns="76200" rIns="76200" bIns="76200" rtlCol="0" anchor="t"/>
-          <a:lstStyle/>
-          <a:p>
-            <a:pPr indent="0" marL="0">
-              <a:buNone/>
-            </a:pPr>
-            <a:r>
-              <a:rPr lang="en-US" sz="1700" dirty="0">
+            <a:off x="6949440" y="1783080"/>
+            <a:ext cx="1828800" cy="2651760"/>
+          </a:xfrm>
+          <a:prstGeom prst="rect">
+            <a:avLst/>
+          </a:prstGeom>
+          <a:noFill/>
+          <a:ln/>
+        </p:spPr>
+        <p:txBody>
+          <a:bodyPr wrap="square" lIns="50800" tIns="50800" rIns="50800" bIns="50800" rtlCol="0" anchor="t"/>
+          <a:lstStyle/>
+          <a:p>
+            <a:pPr marL="342900" indent="-342900">
+              <a:spcAft>
+                <a:spcPts val="1000"/>
+              </a:spcAft>
+              <a:buSzPct val="100000"/>
+              <a:buChar char="•"/>
+            </a:pPr>
+            <a:r>
+              <a:rPr lang="en-US" sz="1500" dirty="0">
                 <a:solidFill>
                   <a:srgbClr val="3D3D3D"/>
                 </a:solidFill>
@@ -7834,48 +7976,51 @@
                 <a:ea typeface="微軟正黑體" pitchFamily="34" charset="-122"/>
                 <a:cs typeface="微軟正黑體" pitchFamily="34" charset="-120"/>
               </a:rPr>
-              <a:t>縮短製作時間、素材一致、可系列化重複使用，並可追蹤成效</a:t>
-            </a:r>
-            <a:endParaRPr lang="en-US" sz="1700" dirty="0"/>
-          </a:p>
-        </p:txBody>
-      </p:sp>
-      <p:sp>
-        <p:nvSpPr>
-          <p:cNvPr id="23" name="Text 21"/>
-          <p:cNvSpPr/>
-          <p:nvPr/>
-        </p:nvSpPr>
-        <p:spPr>
-          <a:xfrm>
-            <a:off x="274320" y="4434840"/>
-            <a:ext cx="8229600" cy="274320"/>
-          </a:xfrm>
-          <a:prstGeom prst="rect">
-            <a:avLst/>
-          </a:prstGeom>
-          <a:noFill/>
-          <a:ln/>
-        </p:spPr>
-        <p:txBody>
-          <a:bodyPr wrap="square" lIns="0" tIns="0" rIns="0" bIns="0" rtlCol="0" anchor="ctr"/>
-          <a:lstStyle/>
-          <a:p>
-            <a:pPr indent="0" marL="0">
-              <a:buNone/>
-            </a:pPr>
-            <a:r>
-              <a:rPr lang="en-US" sz="1100" dirty="0">
-                <a:solidFill>
-                  <a:srgbClr val="7A7A7A"/>
-                </a:solidFill>
-                <a:latin typeface="微軟正黑體" pitchFamily="34" charset="0"/>
-                <a:ea typeface="微軟正黑體" pitchFamily="34" charset="-122"/>
-                <a:cs typeface="微軟正黑體" pitchFamily="34" charset="-120"/>
-              </a:rPr>
-              <a:t>註：現況描述請依單位實際情形調整，並補上量化數據。</a:t>
-            </a:r>
-            <a:endParaRPr lang="en-US" sz="1100" dirty="0"/>
+              <a:t>縮短素材製作時間</a:t>
+            </a:r>
+            <a:endParaRPr lang="en-US" sz="1500" dirty="0"/>
+          </a:p>
+          <a:p>
+            <a:pPr marL="342900" indent="-342900">
+              <a:spcAft>
+                <a:spcPts val="1000"/>
+              </a:spcAft>
+              <a:buSzPct val="100000"/>
+              <a:buChar char="•"/>
+            </a:pPr>
+            <a:r>
+              <a:rPr lang="en-US" sz="1500" dirty="0">
+                <a:solidFill>
+                  <a:srgbClr val="3D3D3D"/>
+                </a:solidFill>
+                <a:latin typeface="微軟正黑體" pitchFamily="34" charset="0"/>
+                <a:ea typeface="微軟正黑體" pitchFamily="34" charset="-122"/>
+                <a:cs typeface="微軟正黑體" pitchFamily="34" charset="-120"/>
+              </a:rPr>
+              <a:t>同一角色與風格，系列素材一致</a:t>
+            </a:r>
+            <a:endParaRPr lang="en-US" sz="1500" dirty="0"/>
+          </a:p>
+          <a:p>
+            <a:pPr marL="342900" indent="-342900">
+              <a:spcAft>
+                <a:spcPts val="1000"/>
+              </a:spcAft>
+              <a:buSzPct val="100000"/>
+              <a:buChar char="•"/>
+            </a:pPr>
+            <a:r>
+              <a:rPr lang="en-US" sz="1500" dirty="0">
+                <a:solidFill>
+                  <a:srgbClr val="3D3D3D"/>
+                </a:solidFill>
+                <a:latin typeface="微軟正黑體" pitchFamily="34" charset="0"/>
+                <a:ea typeface="微軟正黑體" pitchFamily="34" charset="-122"/>
+                <a:cs typeface="微軟正黑體" pitchFamily="34" charset="-120"/>
+              </a:rPr>
+              <a:t>可重複使用，並可追蹤成效</a:t>
+            </a:r>
+            <a:endParaRPr lang="en-US" sz="1500" dirty="0"/>
           </a:p>
         </p:txBody>
       </p:sp>

</xml_diff>